<commit_message>
small updates for 2026
</commit_message>
<xml_diff>
--- a/Day1/intro_to_git.pptx
+++ b/Day1/intro_to_git.pptx
@@ -210,7 +210,7 @@
           <a:p>
             <a:fld id="{804BB16D-6A3A-0143-BE35-4D7955F2C534}" type="datetimeFigureOut">
               <a:rPr lang="en-US" smtClean="0"/>
-              <a:t>8/4/25</a:t>
+              <a:t>6/16/26</a:t>
             </a:fld>
             <a:endParaRPr lang="en-US"/>
           </a:p>
@@ -733,7 +733,7 @@
           <a:p>
             <a:fld id="{34073DC1-AB27-4363-9845-555972D7C4F0}" type="datetimeFigureOut">
               <a:rPr lang="en-US" smtClean="0"/>
-              <a:t>8/4/25</a:t>
+              <a:t>6/16/26</a:t>
             </a:fld>
             <a:endParaRPr lang="en-US"/>
           </a:p>
@@ -931,7 +931,7 @@
           <a:p>
             <a:fld id="{34073DC1-AB27-4363-9845-555972D7C4F0}" type="datetimeFigureOut">
               <a:rPr lang="en-US" smtClean="0"/>
-              <a:t>8/4/25</a:t>
+              <a:t>6/16/26</a:t>
             </a:fld>
             <a:endParaRPr lang="en-US"/>
           </a:p>
@@ -1139,7 +1139,7 @@
           <a:p>
             <a:fld id="{34073DC1-AB27-4363-9845-555972D7C4F0}" type="datetimeFigureOut">
               <a:rPr lang="en-US" smtClean="0"/>
-              <a:t>8/4/25</a:t>
+              <a:t>6/16/26</a:t>
             </a:fld>
             <a:endParaRPr lang="en-US"/>
           </a:p>
@@ -1337,7 +1337,7 @@
           <a:p>
             <a:fld id="{34073DC1-AB27-4363-9845-555972D7C4F0}" type="datetimeFigureOut">
               <a:rPr lang="en-US" smtClean="0"/>
-              <a:t>8/4/25</a:t>
+              <a:t>6/16/26</a:t>
             </a:fld>
             <a:endParaRPr lang="en-US"/>
           </a:p>
@@ -1612,7 +1612,7 @@
           <a:p>
             <a:fld id="{34073DC1-AB27-4363-9845-555972D7C4F0}" type="datetimeFigureOut">
               <a:rPr lang="en-US" smtClean="0"/>
-              <a:t>8/4/25</a:t>
+              <a:t>6/16/26</a:t>
             </a:fld>
             <a:endParaRPr lang="en-US"/>
           </a:p>
@@ -1877,7 +1877,7 @@
           <a:p>
             <a:fld id="{34073DC1-AB27-4363-9845-555972D7C4F0}" type="datetimeFigureOut">
               <a:rPr lang="en-US" smtClean="0"/>
-              <a:t>8/4/25</a:t>
+              <a:t>6/16/26</a:t>
             </a:fld>
             <a:endParaRPr lang="en-US"/>
           </a:p>
@@ -2289,7 +2289,7 @@
           <a:p>
             <a:fld id="{34073DC1-AB27-4363-9845-555972D7C4F0}" type="datetimeFigureOut">
               <a:rPr lang="en-US" smtClean="0"/>
-              <a:t>8/4/25</a:t>
+              <a:t>6/16/26</a:t>
             </a:fld>
             <a:endParaRPr lang="en-US"/>
           </a:p>
@@ -2430,7 +2430,7 @@
           <a:p>
             <a:fld id="{34073DC1-AB27-4363-9845-555972D7C4F0}" type="datetimeFigureOut">
               <a:rPr lang="en-US" smtClean="0"/>
-              <a:t>8/4/25</a:t>
+              <a:t>6/16/26</a:t>
             </a:fld>
             <a:endParaRPr lang="en-US"/>
           </a:p>
@@ -2543,7 +2543,7 @@
           <a:p>
             <a:fld id="{34073DC1-AB27-4363-9845-555972D7C4F0}" type="datetimeFigureOut">
               <a:rPr lang="en-US" smtClean="0"/>
-              <a:t>8/4/25</a:t>
+              <a:t>6/16/26</a:t>
             </a:fld>
             <a:endParaRPr lang="en-US"/>
           </a:p>
@@ -2854,7 +2854,7 @@
           <a:p>
             <a:fld id="{34073DC1-AB27-4363-9845-555972D7C4F0}" type="datetimeFigureOut">
               <a:rPr lang="en-US" smtClean="0"/>
-              <a:t>8/4/25</a:t>
+              <a:t>6/16/26</a:t>
             </a:fld>
             <a:endParaRPr lang="en-US"/>
           </a:p>
@@ -3142,7 +3142,7 @@
           <a:p>
             <a:fld id="{34073DC1-AB27-4363-9845-555972D7C4F0}" type="datetimeFigureOut">
               <a:rPr lang="en-US" smtClean="0"/>
-              <a:t>8/4/25</a:t>
+              <a:t>6/16/26</a:t>
             </a:fld>
             <a:endParaRPr lang="en-US"/>
           </a:p>
@@ -3383,7 +3383,7 @@
           <a:p>
             <a:fld id="{34073DC1-AB27-4363-9845-555972D7C4F0}" type="datetimeFigureOut">
               <a:rPr lang="en-US" smtClean="0"/>
-              <a:t>8/4/25</a:t>
+              <a:t>6/16/26</a:t>
             </a:fld>
             <a:endParaRPr lang="en-US"/>
           </a:p>
@@ -3861,7 +3861,7 @@
           <a:p>
             <a:r>
               <a:rPr lang="en-US" dirty="0"/>
-              <a:t>Code/Astro 2025</a:t>
+              <a:t>Code/Astro 2026</a:t>
             </a:r>
           </a:p>
         </p:txBody>
@@ -4965,7 +4965,7 @@
             </a:pPr>
             <a:r>
               <a:rPr lang="en-US" dirty="0"/>
-              <a:t>Don’t try to type along with me as we walk through the demo. We’ll have time at the end to work on the demo in groups. </a:t>
+              <a:t>Feel free to code alone with the demo, but don’t worry if you hit a bug somewhere. We’ll have time at the end to work on the demo in groups. </a:t>
             </a:r>
           </a:p>
           <a:p>

</xml_diff>